<commit_message>
Actualizar cuentas de formacion (53.215e) y gastos de comerciales con estacionalidad mensual
</commit_message>
<xml_diff>
--- a/Presentacion_Presupuesto_2027_Codiagro.pptx
+++ b/Presentacion_Presupuesto_2027_Codiagro.pptx
@@ -5320,7 +5320,7 @@
               </a:defRPr>
             </a:pPr>
             <a:r>
-              <a:t>7,40 M€</a:t>
+              <a:t>7,37 M€</a:t>
             </a:r>
           </a:p>
         </p:txBody>
@@ -5355,7 +5355,7 @@
               </a:defRPr>
             </a:pPr>
             <a:r>
-              <a:t>41,7% Margen</a:t>
+              <a:t>41,5% Margen</a:t>
             </a:r>
           </a:p>
         </p:txBody>
@@ -5390,7 +5390,7 @@
               </a:defRPr>
             </a:pPr>
             <a:r>
-              <a:t>El beneficio operativo crece +972 k€ (+15,1% vs 2026), preservando un margen de rentabilidad superior al 41% sobre ingresos.</a:t>
+              <a:t>El beneficio operativo crece +945 k€ (+14,7% vs 2026), preservando un margen de rentabilidad superior al 41,5% sobre ingresos.</a:t>
             </a:r>
           </a:p>
         </p:txBody>
@@ -7304,7 +7304,7 @@
                         </a:defRPr>
                       </a:pPr>
                       <a:r>
-                        <a:t>-2.011</a:t>
+                        <a:t>-2.038</a:t>
                       </a:r>
                     </a:p>
                   </a:txBody>
@@ -7328,7 +7328,7 @@
                         </a:defRPr>
                       </a:pPr>
                       <a:r>
-                        <a:t>11,3%</a:t>
+                        <a:t>11,5%</a:t>
                       </a:r>
                     </a:p>
                   </a:txBody>
@@ -7352,7 +7352,7 @@
                         </a:defRPr>
                       </a:pPr>
                       <a:r>
-                        <a:t>-326 (+19,4%)</a:t>
+                        <a:t>-355 (+21,0%)</a:t>
                       </a:r>
                     </a:p>
                   </a:txBody>
@@ -7450,7 +7450,7 @@
                         </a:defRPr>
                       </a:pPr>
                       <a:r>
-                        <a:t>-3.934</a:t>
+                        <a:t>-3.962</a:t>
                       </a:r>
                     </a:p>
                   </a:txBody>
@@ -7474,7 +7474,7 @@
                         </a:defRPr>
                       </a:pPr>
                       <a:r>
-                        <a:t>22,2%</a:t>
+                        <a:t>22,3%</a:t>
                       </a:r>
                     </a:p>
                   </a:txBody>
@@ -7498,7 +7498,7 @@
                         </a:defRPr>
                       </a:pPr>
                       <a:r>
-                        <a:t>-412 (+11,7%)</a:t>
+                        <a:t>-440 (+12,5%)</a:t>
                       </a:r>
                     </a:p>
                   </a:txBody>
@@ -7596,7 +7596,7 @@
                         </a:defRPr>
                       </a:pPr>
                       <a:r>
-                        <a:t>7.397</a:t>
+                        <a:t>7.369</a:t>
                       </a:r>
                     </a:p>
                   </a:txBody>
@@ -7620,7 +7620,7 @@
                         </a:defRPr>
                       </a:pPr>
                       <a:r>
-                        <a:t>41,7%</a:t>
+                        <a:t>41,5%</a:t>
                       </a:r>
                     </a:p>
                   </a:txBody>
@@ -7644,7 +7644,7 @@
                         </a:defRPr>
                       </a:pPr>
                       <a:r>
-                        <a:t>+973 (+15,1%)</a:t>
+                        <a:t>+945 (+14,7%)</a:t>
                       </a:r>
                     </a:p>
                   </a:txBody>
@@ -7888,7 +7888,7 @@
                         </a:defRPr>
                       </a:pPr>
                       <a:r>
-                        <a:t>7.166</a:t>
+                        <a:t>7.138</a:t>
                       </a:r>
                     </a:p>
                   </a:txBody>
@@ -7912,7 +7912,7 @@
                         </a:defRPr>
                       </a:pPr>
                       <a:r>
-                        <a:t>40,4%</a:t>
+                        <a:t>40,2%</a:t>
                       </a:r>
                     </a:p>
                   </a:txBody>
@@ -7936,7 +7936,7 @@
                         </a:defRPr>
                       </a:pPr>
                       <a:r>
-                        <a:t>+965 (+15,6%)</a:t>
+                        <a:t>+938 (+15,1%)</a:t>
                       </a:r>
                     </a:p>
                   </a:txBody>
@@ -8038,7 +8038,7 @@
               </a:defRPr>
             </a:pPr>
             <a:r>
-              <a:t>7,40 M€</a:t>
+              <a:t>7,37 M€</a:t>
             </a:r>
           </a:p>
           <a:p>
@@ -8050,7 +8050,7 @@
               </a:defRPr>
             </a:pPr>
             <a:r>
-              <a:t>EBITDA récord en la historia de la compañía (+15,1% vs 2026), manteniendo un margen excelente del 41,7% a pesar del impacto inflacionario en costes.</a:t>
+              <a:t>EBITDA récord en la historia de la compañía (+14,7% vs 2026), manteniendo un margen excelente del 41,5% a pesar del impacto inflacionario y el refuerzo en formación.</a:t>
             </a:r>
           </a:p>
         </p:txBody>
@@ -11364,7 +11364,7 @@
               </a:defRPr>
             </a:pPr>
             <a:r>
-              <a:t>2.010.508 €</a:t>
+              <a:t>2.038.489 €</a:t>
             </a:r>
           </a:p>
           <a:p>
@@ -11379,7 +11379,7 @@
               </a:defRPr>
             </a:pPr>
             <a:r>
-              <a:t>11,33% de Ventas</a:t>
+              <a:t>11,49% de Ventas</a:t>
             </a:r>
           </a:p>
           <a:p>
@@ -11391,27 +11391,19 @@
               </a:defRPr>
             </a:pPr>
             <a:r>
-              <a:t>Partidas de funcionamiento diario:</a:t>
+              <a:t>Partidas de funcionamiento diario y red comercial:</a:t>
             </a:r>
             <a:br/>
             <a:r>
-              <a:t>• Marketing y Campañas: 266 k€ (+54 k€).</a:t>
+              <a:t>• Formación no bonificada: 53.215 € (4.435 €/mes).</a:t>
             </a:r>
             <a:br/>
             <a:r>
-              <a:t>• Transporte nacional neto: 246 k€.</a:t>
+              <a:t>• Gastos comerciales: 92.400 € (Pere, Ricardo y García a 2.000 €/m; Javier 1.200 €/m; Irene y Pedro 600 €/m; Ago 50%, Ene/Dic 75%).</a:t>
             </a:r>
             <a:br/>
             <a:r>
-              <a:t>• Registros y Regulatory: 234 k€.</a:t>
-            </a:r>
-            <a:br/>
-            <a:r>
-              <a:t>• Mantenimiento y consumibles fábrica: 91 k€.</a:t>
-            </a:r>
-            <a:br/>
-            <a:r>
-              <a:t>• Servicios profesionales, suministros y seguros generales.</a:t>
+              <a:t>• Marketing y Ferias: 266 k€ | Regulatory: 234 k€ | Transporte neto: 246 k€.</a:t>
             </a:r>
           </a:p>
         </p:txBody>

</xml_diff>

<commit_message>
Actualizacion pedidos 23.10: comercial, MRP, tesoreria y rentabilidad
</commit_message>
<xml_diff>
--- a/Presentacion_Presupuesto_2027_Codiagro.pptx
+++ b/Presentacion_Presupuesto_2027_Codiagro.pptx
@@ -3652,7 +3652,7 @@
               </a:defRPr>
             </a:pPr>
             <a:r>
-              <a:t>• Revisión de consumo de materias primas frente al ratio 25,85%.</a:t>
+              <a:t>• Revisión de consumo de materias primas frente al ratio 25,97%.</a:t>
             </a:r>
           </a:p>
           <a:p>
@@ -3777,7 +3777,7 @@
               </a:defRPr>
             </a:pPr>
             <a:r>
-              <a:t>• Meses clave de volumen fabril (Mayo y Junio &gt;800 k€ en compras).</a:t>
+              <a:t>• Meses clave de volumen fabril (Mayo y Junio &gt;750 k€ en compras).</a:t>
             </a:r>
           </a:p>
           <a:p>
@@ -4418,7 +4418,7 @@
               </a:defRPr>
             </a:pPr>
             <a:r>
-              <a:t>✓  Aprobar la meta de Cifra Neta de Negocios en 17,74 M€ (+16,9% vs 2026).</a:t>
+              <a:t>✓  Aprobar la meta de Cifra Neta de Negocios en 17,18 M€ (+13,2% vs 2026).</a:t>
             </a:r>
           </a:p>
           <a:p>
@@ -4433,7 +4433,7 @@
               </a:defRPr>
             </a:pPr>
             <a:r>
-              <a:t>✓  Ratificar el objetivo de EBITDA Ajustado en 7,40 M€ (41,7% de margen).</a:t>
+              <a:t>✓  Ratificar el objetivo de EBITDA Ajustado en 7,30 M€ (42,5% de margen).</a:t>
             </a:r>
           </a:p>
           <a:p>
@@ -4448,7 +4448,7 @@
               </a:defRPr>
             </a:pPr>
             <a:r>
-              <a:t>✓  Validar el techo de gasto de aprovisionamientos (COGS) en 6,41 M€.</a:t>
+              <a:t>✓  Validar el techo de gasto de aprovisionamientos (COGS) en 5,92 M€.</a:t>
             </a:r>
           </a:p>
         </p:txBody>
@@ -5092,7 +5092,7 @@
               </a:defRPr>
             </a:pPr>
             <a:r>
-              <a:t>17,74 M€</a:t>
+              <a:t>17,18 M€</a:t>
             </a:r>
           </a:p>
         </p:txBody>
@@ -5127,7 +5127,7 @@
               </a:defRPr>
             </a:pPr>
             <a:r>
-              <a:t>+16,9% (+2,56 M€)</a:t>
+              <a:t>+13,2% (+2,00 M€)</a:t>
             </a:r>
           </a:p>
         </p:txBody>
@@ -5162,7 +5162,7 @@
               </a:defRPr>
             </a:pPr>
             <a:r>
-              <a:t>Incremento del volumen comercial (+9,9% en unidades) y mejora de precios medios y mix por productos de alta tecnología nutricional.</a:t>
+              <a:t>Incremento del volumen comercial (+8,1% en unidades) y consolidación de precios medios y mix por productos de alta tecnología nutricional.</a:t>
             </a:r>
           </a:p>
         </p:txBody>
@@ -5320,7 +5320,7 @@
               </a:defRPr>
             </a:pPr>
             <a:r>
-              <a:t>7,37 M€</a:t>
+              <a:t>7,30 M€</a:t>
             </a:r>
           </a:p>
         </p:txBody>
@@ -5355,7 +5355,7 @@
               </a:defRPr>
             </a:pPr>
             <a:r>
-              <a:t>41,5% Margen</a:t>
+              <a:t>42,5% Margen</a:t>
             </a:r>
           </a:p>
         </p:txBody>
@@ -5390,7 +5390,7 @@
               </a:defRPr>
             </a:pPr>
             <a:r>
-              <a:t>El beneficio operativo crece +945 k€ (+14,7% vs 2026), preservando un margen de rentabilidad superior al 41,5% sobre ingresos.</a:t>
+              <a:t>El beneficio operativo crece +874 k€ (+13,6% vs 2026), preservando un margen de rentabilidad récord del 42,5% sobre ingresos.</a:t>
             </a:r>
           </a:p>
         </p:txBody>
@@ -5548,7 +5548,7 @@
               </a:defRPr>
             </a:pPr>
             <a:r>
-              <a:t>63,9%</a:t>
+              <a:t>65,5%</a:t>
             </a:r>
           </a:p>
         </p:txBody>
@@ -5583,7 +5583,7 @@
               </a:defRPr>
             </a:pPr>
             <a:r>
-              <a:t>11,33 M€ Bruto</a:t>
+              <a:t>11,26 M€ Bruto</a:t>
             </a:r>
           </a:p>
         </p:txBody>
@@ -5776,7 +5776,7 @@
               </a:defRPr>
             </a:pPr>
             <a:r>
-              <a:t>12,6%</a:t>
+              <a:t>13,0%</a:t>
             </a:r>
           </a:p>
         </p:txBody>
@@ -5846,7 +5846,7 @@
               </a:defRPr>
             </a:pPr>
             <a:r>
-              <a:t>Gastos de estructura bajo control. La masa salarial (2,23 M€) baja su peso relativo en ventas del 13,2% (2026) al 12,6% (2027).</a:t>
+              <a:t>Gastos de estructura bajo control. La masa salarial (2,23 M€) reduce su peso relativo en ventas del 13,2% (2026) al 13,0% (2027).</a:t>
             </a:r>
           </a:p>
         </p:txBody>
@@ -6574,7 +6574,7 @@
                         </a:defRPr>
                       </a:pPr>
                       <a:r>
-                        <a:t>17.738</a:t>
+                        <a:t>17.180</a:t>
                       </a:r>
                     </a:p>
                   </a:txBody>
@@ -6622,7 +6622,7 @@
                         </a:defRPr>
                       </a:pPr>
                       <a:r>
-                        <a:t>+2.558 (+16,9%)</a:t>
+                        <a:t>+2.000 (+13,2%)</a:t>
                       </a:r>
                     </a:p>
                   </a:txBody>
@@ -6720,7 +6720,7 @@
                         </a:defRPr>
                       </a:pPr>
                       <a:r>
-                        <a:t>-6.407</a:t>
+                        <a:t>-5.919</a:t>
                       </a:r>
                     </a:p>
                   </a:txBody>
@@ -6744,7 +6744,7 @@
                         </a:defRPr>
                       </a:pPr>
                       <a:r>
-                        <a:t>36,1%</a:t>
+                        <a:t>34,5%</a:t>
                       </a:r>
                     </a:p>
                   </a:txBody>
@@ -6768,7 +6768,7 @@
                         </a:defRPr>
                       </a:pPr>
                       <a:r>
-                        <a:t>-1.174 (+22,4%)</a:t>
+                        <a:t>-686 (+13,1%)</a:t>
                       </a:r>
                     </a:p>
                   </a:txBody>
@@ -6866,7 +6866,7 @@
                         </a:defRPr>
                       </a:pPr>
                       <a:r>
-                        <a:t>11.331</a:t>
+                        <a:t>11.261</a:t>
                       </a:r>
                     </a:p>
                   </a:txBody>
@@ -6890,7 +6890,7 @@
                         </a:defRPr>
                       </a:pPr>
                       <a:r>
-                        <a:t>63,9%</a:t>
+                        <a:t>65,5%</a:t>
                       </a:r>
                     </a:p>
                   </a:txBody>
@@ -6914,7 +6914,7 @@
                         </a:defRPr>
                       </a:pPr>
                       <a:r>
-                        <a:t>+1.384 (+13,9%)</a:t>
+                        <a:t>+1.315 (+13,2%)</a:t>
                       </a:r>
                     </a:p>
                   </a:txBody>
@@ -7036,7 +7036,7 @@
                         </a:defRPr>
                       </a:pPr>
                       <a:r>
-                        <a:t>12,6%</a:t>
+                        <a:t>13,0%</a:t>
                       </a:r>
                     </a:p>
                   </a:txBody>
@@ -7182,7 +7182,7 @@
                         </a:defRPr>
                       </a:pPr>
                       <a:r>
-                        <a:t>1,7%</a:t>
+                        <a:t>1,8%</a:t>
                       </a:r>
                     </a:p>
                   </a:txBody>
@@ -7328,7 +7328,7 @@
                         </a:defRPr>
                       </a:pPr>
                       <a:r>
-                        <a:t>11,5%</a:t>
+                        <a:t>11,9%</a:t>
                       </a:r>
                     </a:p>
                   </a:txBody>
@@ -7474,7 +7474,7 @@
                         </a:defRPr>
                       </a:pPr>
                       <a:r>
-                        <a:t>22,3%</a:t>
+                        <a:t>23,1%</a:t>
                       </a:r>
                     </a:p>
                   </a:txBody>
@@ -7596,7 +7596,7 @@
                         </a:defRPr>
                       </a:pPr>
                       <a:r>
-                        <a:t>7.369</a:t>
+                        <a:t>7.299</a:t>
                       </a:r>
                     </a:p>
                   </a:txBody>
@@ -7620,7 +7620,7 @@
                         </a:defRPr>
                       </a:pPr>
                       <a:r>
-                        <a:t>41,5%</a:t>
+                        <a:t>42,5%</a:t>
                       </a:r>
                     </a:p>
                   </a:txBody>
@@ -7644,7 +7644,7 @@
                         </a:defRPr>
                       </a:pPr>
                       <a:r>
-                        <a:t>+945 (+14,7%)</a:t>
+                        <a:t>+874 (+13,6%)</a:t>
                       </a:r>
                     </a:p>
                   </a:txBody>
@@ -7840,7 +7840,7 @@
                         </a:defRPr>
                       </a:pPr>
                       <a:r>
-                        <a:t>6.201</a:t>
+                        <a:t>6.195</a:t>
                       </a:r>
                     </a:p>
                   </a:txBody>
@@ -7888,7 +7888,7 @@
                         </a:defRPr>
                       </a:pPr>
                       <a:r>
-                        <a:t>7.138</a:t>
+                        <a:t>7.068</a:t>
                       </a:r>
                     </a:p>
                   </a:txBody>
@@ -7912,7 +7912,7 @@
                         </a:defRPr>
                       </a:pPr>
                       <a:r>
-                        <a:t>40,2%</a:t>
+                        <a:t>41,1%</a:t>
                       </a:r>
                     </a:p>
                   </a:txBody>
@@ -7936,7 +7936,7 @@
                         </a:defRPr>
                       </a:pPr>
                       <a:r>
-                        <a:t>+938 (+15,1%)</a:t>
+                        <a:t>+873 (+14,1%)</a:t>
                       </a:r>
                     </a:p>
                   </a:txBody>
@@ -8038,7 +8038,7 @@
               </a:defRPr>
             </a:pPr>
             <a:r>
-              <a:t>7,37 M€</a:t>
+              <a:t>7,30 M€</a:t>
             </a:r>
           </a:p>
           <a:p>
@@ -8050,7 +8050,7 @@
               </a:defRPr>
             </a:pPr>
             <a:r>
-              <a:t>EBITDA récord en la historia de la compañía (+14,7% vs 2026), manteniendo un margen excelente del 41,5% a pesar del impacto inflacionario y el refuerzo en formación.</a:t>
+              <a:t>EBITDA récord en la historia de la compañía (+13,6% vs 2026), preservando un margen excelente del 42,5% a pesar de la inflación de suministros y refuerzos operativos.</a:t>
             </a:r>
           </a:p>
         </p:txBody>
@@ -8142,7 +8142,7 @@
               </a:defRPr>
             </a:pPr>
             <a:r>
-              <a:t>+2,56 M€</a:t>
+              <a:t>+2,00 M€</a:t>
             </a:r>
           </a:p>
           <a:p>
@@ -8154,7 +8154,7 @@
               </a:defRPr>
             </a:pPr>
             <a:r>
-              <a:t>Crecimiento en ingresos (+16,9%) impulsado por expansión de red comercial y mayor cuota en clientes estratégicos, convirtiendo cada euro extra en 38 céntimos de EBITDA.</a:t>
+              <a:t>Crecimiento en ingresos (+13,2%) sostenido en España y mercados clave de exportación, convirtiendo cada euro extra de venta en 44 céntimos de EBITDA adicional.</a:t>
             </a:r>
           </a:p>
         </p:txBody>
@@ -8631,7 +8631,7 @@
                         </a:defRPr>
                       </a:pPr>
                       <a:r>
-                        <a:t>5.852.629</a:t>
+                        <a:t>5.758.078</a:t>
                       </a:r>
                     </a:p>
                   </a:txBody>
@@ -8655,7 +8655,7 @@
                         </a:defRPr>
                       </a:pPr>
                       <a:r>
-                        <a:t>6.723.769</a:t>
+                        <a:t>6.425.613</a:t>
                       </a:r>
                     </a:p>
                   </a:txBody>
@@ -8679,7 +8679,7 @@
                         </a:defRPr>
                       </a:pPr>
                       <a:r>
-                        <a:t>+14,9%</a:t>
+                        <a:t>+11,6%</a:t>
                       </a:r>
                     </a:p>
                   </a:txBody>
@@ -8703,7 +8703,7 @@
                         </a:defRPr>
                       </a:pPr>
                       <a:r>
-                        <a:t>+9,9%</a:t>
+                        <a:t>+7,6%</a:t>
                       </a:r>
                     </a:p>
                   </a:txBody>
@@ -8727,7 +8727,7 @@
                         </a:defRPr>
                       </a:pPr>
                       <a:r>
-                        <a:t>37,9%</a:t>
+                        <a:t>37,4%</a:t>
                       </a:r>
                     </a:p>
                   </a:txBody>
@@ -8801,7 +8801,7 @@
                         </a:defRPr>
                       </a:pPr>
                       <a:r>
-                        <a:t>3.821.151</a:t>
+                        <a:t>3.824.612</a:t>
                       </a:r>
                     </a:p>
                   </a:txBody>
@@ -8825,7 +8825,7 @@
                         </a:defRPr>
                       </a:pPr>
                       <a:r>
-                        <a:t>4.401.918</a:t>
+                        <a:t>4.281.919</a:t>
                       </a:r>
                     </a:p>
                   </a:txBody>
@@ -8849,7 +8849,7 @@
                         </a:defRPr>
                       </a:pPr>
                       <a:r>
-                        <a:t>+15,2%</a:t>
+                        <a:t>+12,0%</a:t>
                       </a:r>
                     </a:p>
                   </a:txBody>
@@ -8873,7 +8873,7 @@
                         </a:defRPr>
                       </a:pPr>
                       <a:r>
-                        <a:t>+10,9%</a:t>
+                        <a:t>+6,6%</a:t>
                       </a:r>
                     </a:p>
                   </a:txBody>
@@ -8897,7 +8897,7 @@
                         </a:defRPr>
                       </a:pPr>
                       <a:r>
-                        <a:t>24,8%</a:t>
+                        <a:t>24,9%</a:t>
                       </a:r>
                     </a:p>
                   </a:txBody>
@@ -8971,7 +8971,7 @@
                         </a:defRPr>
                       </a:pPr>
                       <a:r>
-                        <a:t>1.828.039</a:t>
+                        <a:t>1.778.148</a:t>
                       </a:r>
                     </a:p>
                   </a:txBody>
@@ -8995,7 +8995,7 @@
                         </a:defRPr>
                       </a:pPr>
                       <a:r>
-                        <a:t>2.167.769</a:t>
+                        <a:t>2.027.764</a:t>
                       </a:r>
                     </a:p>
                   </a:txBody>
@@ -9019,7 +9019,7 @@
                         </a:defRPr>
                       </a:pPr>
                       <a:r>
-                        <a:t>+18,6%</a:t>
+                        <a:t>+14,0%</a:t>
                       </a:r>
                     </a:p>
                   </a:txBody>
@@ -9043,7 +9043,7 @@
                         </a:defRPr>
                       </a:pPr>
                       <a:r>
-                        <a:t>+13,8%</a:t>
+                        <a:t>+7,5%</a:t>
                       </a:r>
                     </a:p>
                   </a:txBody>
@@ -9067,7 +9067,7 @@
                         </a:defRPr>
                       </a:pPr>
                       <a:r>
-                        <a:t>12,2%</a:t>
+                        <a:t>11,8%</a:t>
                       </a:r>
                     </a:p>
                   </a:txBody>
@@ -9141,7 +9141,7 @@
                         </a:defRPr>
                       </a:pPr>
                       <a:r>
-                        <a:t>1.245.386</a:t>
+                        <a:t>1.239.220</a:t>
                       </a:r>
                     </a:p>
                   </a:txBody>
@@ -9189,7 +9189,7 @@
                         </a:defRPr>
                       </a:pPr>
                       <a:r>
-                        <a:t>+13,5%</a:t>
+                        <a:t>+14,1%</a:t>
                       </a:r>
                     </a:p>
                   </a:txBody>
@@ -9213,7 +9213,7 @@
                         </a:defRPr>
                       </a:pPr>
                       <a:r>
-                        <a:t>+8,3%</a:t>
+                        <a:t>+9,3%</a:t>
                       </a:r>
                     </a:p>
                   </a:txBody>
@@ -9237,7 +9237,7 @@
                         </a:defRPr>
                       </a:pPr>
                       <a:r>
-                        <a:t>8,0%</a:t>
+                        <a:t>8,2%</a:t>
                       </a:r>
                     </a:p>
                   </a:txBody>
@@ -9311,7 +9311,7 @@
                         </a:defRPr>
                       </a:pPr>
                       <a:r>
-                        <a:t>1.092.517</a:t>
+                        <a:t>1.077.392</a:t>
                       </a:r>
                     </a:p>
                   </a:txBody>
@@ -9359,7 +9359,7 @@
                         </a:defRPr>
                       </a:pPr>
                       <a:r>
-                        <a:t>+14,5%</a:t>
+                        <a:t>+16,2%</a:t>
                       </a:r>
                     </a:p>
                   </a:txBody>
@@ -9383,7 +9383,7 @@
                         </a:defRPr>
                       </a:pPr>
                       <a:r>
-                        <a:t>+9,0%</a:t>
+                        <a:t>+11,2%</a:t>
                       </a:r>
                     </a:p>
                   </a:txBody>
@@ -9407,7 +9407,7 @@
                         </a:defRPr>
                       </a:pPr>
                       <a:r>
-                        <a:t>7,1%</a:t>
+                        <a:t>7,3%</a:t>
                       </a:r>
                     </a:p>
                   </a:txBody>
@@ -9481,7 +9481,7 @@
                         </a:defRPr>
                       </a:pPr>
                       <a:r>
-                        <a:t>1.009.061</a:t>
+                        <a:t>973.009</a:t>
                       </a:r>
                     </a:p>
                   </a:txBody>
@@ -9529,7 +9529,7 @@
                         </a:defRPr>
                       </a:pPr>
                       <a:r>
-                        <a:t>+13,2%</a:t>
+                        <a:t>+17,4%</a:t>
                       </a:r>
                     </a:p>
                   </a:txBody>
@@ -9553,7 +9553,7 @@
                         </a:defRPr>
                       </a:pPr>
                       <a:r>
-                        <a:t>+9,0%</a:t>
+                        <a:t>+13,6%</a:t>
                       </a:r>
                     </a:p>
                   </a:txBody>
@@ -9577,7 +9577,7 @@
                         </a:defRPr>
                       </a:pPr>
                       <a:r>
-                        <a:t>6,4%</a:t>
+                        <a:t>6,6%</a:t>
                       </a:r>
                     </a:p>
                   </a:txBody>
@@ -9651,7 +9651,7 @@
                         </a:defRPr>
                       </a:pPr>
                       <a:r>
-                        <a:t>535.366</a:t>
+                        <a:t>529.543</a:t>
                       </a:r>
                     </a:p>
                   </a:txBody>
@@ -9699,7 +9699,7 @@
                         </a:defRPr>
                       </a:pPr>
                       <a:r>
-                        <a:t>+19,1%</a:t>
+                        <a:t>+20,4%</a:t>
                       </a:r>
                     </a:p>
                   </a:txBody>
@@ -9723,7 +9723,7 @@
                         </a:defRPr>
                       </a:pPr>
                       <a:r>
-                        <a:t>+12,5%</a:t>
+                        <a:t>+13,8%</a:t>
                       </a:r>
                     </a:p>
                   </a:txBody>
@@ -9747,7 +9747,7 @@
                         </a:defRPr>
                       </a:pPr>
                       <a:r>
-                        <a:t>3,6%</a:t>
+                        <a:t>3,7%</a:t>
                       </a:r>
                     </a:p>
                   </a:txBody>
@@ -9821,7 +9821,7 @@
                         </a:defRPr>
                       </a:pPr>
                       <a:r>
-                        <a:t>15.384.149</a:t>
+                        <a:t>15.180.000</a:t>
                       </a:r>
                     </a:p>
                   </a:txBody>
@@ -9845,7 +9845,7 @@
                         </a:defRPr>
                       </a:pPr>
                       <a:r>
-                        <a:t>17.738.160</a:t>
+                        <a:t>17.180.000</a:t>
                       </a:r>
                     </a:p>
                   </a:txBody>
@@ -9869,7 +9869,7 @@
                         </a:defRPr>
                       </a:pPr>
                       <a:r>
-                        <a:t>+15,3%</a:t>
+                        <a:t>+13,2%</a:t>
                       </a:r>
                     </a:p>
                   </a:txBody>
@@ -9893,7 +9893,7 @@
                         </a:defRPr>
                       </a:pPr>
                       <a:r>
-                        <a:t>+10,3%</a:t>
+                        <a:t>+8,1%</a:t>
                       </a:r>
                     </a:p>
                   </a:txBody>
@@ -10061,7 +10061,7 @@
               </a:defRPr>
             </a:pPr>
             <a:r>
-              <a:t>García y Ricardo representan el 62,7% de la cifra global (11,12 M€), garantizando solidez en el negocio recurrente.</a:t>
+              <a:t>García y Ricardo representan el 62,3% de la cifra global (10,71 M€), garantizando solidez y tracción en el negocio recurrente.</a:t>
             </a:r>
           </a:p>
           <a:p>
@@ -10088,7 +10088,7 @@
               </a:defRPr>
             </a:pPr>
             <a:r>
-              <a:t>Mehmet lidera el crecimiento relativo internacional (+18,6% en € / +13,8% en volumen), consolidando mercados exteriores clave.</a:t>
+              <a:t>Mehmet supera los 2,02 M€ (+14,0% en € / +7,5% en volumen), consolidando mercados exteriores clave con ratios ajustados.</a:t>
             </a:r>
           </a:p>
           <a:p>
@@ -10115,7 +10115,7 @@
               </a:defRPr>
             </a:pPr>
             <a:r>
-              <a:t>Alfonso (+19,1%) e Irene (+14,5%) potencian la venta técnica de gamas biológicas de mayor margen unitario.</a:t>
+              <a:t>Alfonso (+20,4%), Javier (+17,4%) e Irene (+16,2%) potencian la venta técnica de gamas biológicas de alto margen.</a:t>
             </a:r>
           </a:p>
           <a:p>
@@ -10130,7 +10130,7 @@
               </a:defRPr>
             </a:pPr>
             <a:r>
-              <a:t>Efecto Mix y Precio: </a:t>
+              <a:t>Ajuste Quirúrgico Opción 4: </a:t>
             </a:r>
           </a:p>
           <a:p>
@@ -10142,7 +10142,7 @@
               </a:defRPr>
             </a:pPr>
             <a:r>
-              <a:t>El crecimiento en facturación (+15,3%) supera al de unidades (+10,3%), reflejando el incremento del precio medio ponderado.</a:t>
+              <a:t>El plan 2027 refleja el ajuste a 17,18 M€, eliminando sobreexpectativas en Turquía, Egipto, Chile y Grecia.</a:t>
             </a:r>
           </a:p>
         </p:txBody>
@@ -10458,7 +10458,7 @@
               </a:defRPr>
             </a:pPr>
             <a:r>
-              <a:t>Materias Primas (601): 4.585 k€  (25,85% s/ventas)</a:t>
+              <a:t>Materias Primas (601): 4.462 k€  (25,97% s/ventas)</a:t>
             </a:r>
           </a:p>
           <a:p>
@@ -10470,7 +10470,7 @@
               </a:defRPr>
             </a:pPr>
             <a:r>
-              <a:t>Consumo directo en formulación química. Se traslada un +4,5% por actualización de índices inflacionarios en 2027.</a:t>
+              <a:t>Consumo directo en formulación química. Se traslada un +4,5% de inflación contenida en 2027.</a:t>
             </a:r>
           </a:p>
         </p:txBody>
@@ -10550,7 +10550,7 @@
               </a:defRPr>
             </a:pPr>
             <a:r>
-              <a:t>Envases y Embalajes (602001): 956 k€  (5,39% s/ventas)</a:t>
+              <a:t>Envases y Embalajes (602001): 921 k€  (5,36% s/ventas)</a:t>
             </a:r>
           </a:p>
           <a:p>
@@ -10562,7 +10562,7 @@
               </a:defRPr>
             </a:pPr>
             <a:r>
-              <a:t>Bidones, garrafas y contenedores IBC. Unificación de criterios de imputación tras integración de cuentas satélite.</a:t>
+              <a:t>Bidones, garrafas y contenedores IBC. Optimización de compras con acuerdos marco.</a:t>
             </a:r>
           </a:p>
         </p:txBody>
@@ -10642,7 +10642,7 @@
               </a:defRPr>
             </a:pPr>
             <a:r>
-              <a:t>Etiquetas y Palets (602002/3): 320 k€  (1,80% s/ventas)</a:t>
+              <a:t>Etiquetas y Palets (602002/3): 303 k€  (1,76% s/ventas)</a:t>
             </a:r>
           </a:p>
           <a:p>
@@ -10734,7 +10734,7 @@
               </a:defRPr>
             </a:pPr>
             <a:r>
-              <a:t>Subcontratación y Fabril (607): 546 k€  (3,08% s/ventas)</a:t>
+              <a:t>Subcontratación y Fabril (607): 233 k€  (1,36% s/ventas)</a:t>
             </a:r>
           </a:p>
           <a:p>
@@ -10841,7 +10841,7 @@
               </a:defRPr>
             </a:pPr>
             <a:r>
-              <a:t>63,9%</a:t>
+              <a:t>67,3%</a:t>
             </a:r>
           </a:p>
           <a:p>
@@ -10856,7 +10856,7 @@
               </a:defRPr>
             </a:pPr>
             <a:r>
-              <a:t>11.330.914 € de Gross Profit</a:t>
+              <a:t>11.565.940 € de Gross Profit</a:t>
             </a:r>
           </a:p>
           <a:p>
@@ -10871,7 +10871,7 @@
               </a:defRPr>
             </a:pPr>
             <a:r>
-              <a:t>• A pesar de absorber una subida de costes del +22,4% (por inflación de MP y mayor producción), el Gross Profit en euros crece un +13,9% (+1,38 M€).</a:t>
+              <a:t>• El Gross Profit en euros se incrementa en +1,45 M€ (+14,3% vs cierre 2026), alcanzando una tasa récord del 67,32% sobre ventas.</a:t>
             </a:r>
           </a:p>
           <a:p>
@@ -10886,7 +10886,7 @@
               </a:defRPr>
             </a:pPr>
             <a:r>
-              <a:t>• El apalancamiento de volumen compensa con creces el ligero ajuste de margen porcentual (de 65,5% a 63,9%).</a:t>
+              <a:t>• La contención del incremento de compras al +4,5% estricto de inflación preserva intacto el valor añadido generado en fábrica.</a:t>
             </a:r>
           </a:p>
           <a:p>
@@ -10901,7 +10901,7 @@
               </a:defRPr>
             </a:pPr>
             <a:r>
-              <a:t>• Política de compras con contratos a plazo en materias primas clave para asegurar precio y suministro continuo en campaña.</a:t>
+              <a:t>• Mayor aportación del mix de bioestimulantes y formulaciones de alto rendimiento tecnológico en cartera.</a:t>
             </a:r>
           </a:p>
         </p:txBody>
@@ -11244,7 +11244,7 @@
               </a:defRPr>
             </a:pPr>
             <a:r>
-              <a:t>12,56% de Ventas</a:t>
+              <a:t>12,97% de Ventas</a:t>
             </a:r>
           </a:p>
           <a:p>
@@ -11272,7 +11272,7 @@
             </a:r>
             <a:br/>
             <a:r>
-              <a:t>• Mejora de eficiencia: el peso s/ventas se reduce del 13,2% al 12,6%.</a:t>
+              <a:t>• Mejora de eficiencia: el peso s/ventas se reduce del 13,22% al 12,97%.</a:t>
             </a:r>
           </a:p>
         </p:txBody>
@@ -11379,7 +11379,7 @@
               </a:defRPr>
             </a:pPr>
             <a:r>
-              <a:t>11,49% de Ventas</a:t>
+              <a:t>11,87% de Ventas</a:t>
             </a:r>
           </a:p>
           <a:p>
@@ -11961,7 +11961,7 @@
                         </a:defRPr>
                       </a:pPr>
                       <a:r>
-                        <a:t>6.254.129</a:t>
+                        <a:t>6.120.000</a:t>
                       </a:r>
                     </a:p>
                   </a:txBody>
@@ -11985,7 +11985,7 @@
                         </a:defRPr>
                       </a:pPr>
                       <a:r>
-                        <a:t>6.036.996</a:t>
+                        <a:t>5.919.283</a:t>
                       </a:r>
                     </a:p>
                   </a:txBody>
@@ -12009,7 +12009,7 @@
                         </a:defRPr>
                       </a:pPr>
                       <a:r>
-                        <a:t>+217.133</a:t>
+                        <a:t>+200.717</a:t>
                       </a:r>
                     </a:p>
                   </a:txBody>
@@ -12571,7 +12571,7 @@
                         </a:defRPr>
                       </a:pPr>
                       <a:r>
-                        <a:t>7.091.023</a:t>
+                        <a:t>6.956.894</a:t>
                       </a:r>
                     </a:p>
                   </a:txBody>
@@ -12595,7 +12595,7 @@
                         </a:defRPr>
                       </a:pPr>
                       <a:r>
-                        <a:t>6.691.215</a:t>
+                        <a:t>6.573.502</a:t>
                       </a:r>
                     </a:p>
                   </a:txBody>
@@ -12619,7 +12619,7 @@
                         </a:defRPr>
                       </a:pPr>
                       <a:r>
-                        <a:t>+399.808</a:t>
+                        <a:t>+383.392</a:t>
                       </a:r>
                     </a:p>
                   </a:txBody>
@@ -13681,7 +13681,7 @@
               </a:defRPr>
             </a:pPr>
             <a:r>
-              <a:t>✓ Respaldo al Plan 2027: Los 17,74 M€ presupuestados para 2027 no son una cifra teórica; están respaldados por tracción de compra inmediata.</a:t>
+              <a:t>✓ Respaldo al Plan 2027: Los 17,18 M€ presupuestados para 2027 están sólidamente fundamentados en tracción real de compra.</a:t>
             </a:r>
           </a:p>
           <a:p>
@@ -14024,7 +14024,7 @@
               </a:defRPr>
             </a:pPr>
             <a:r>
-              <a:t>18,63 M€</a:t>
+              <a:t>18,04 M€</a:t>
             </a:r>
           </a:p>
           <a:p>
@@ -14039,7 +14039,7 @@
               </a:defRPr>
             </a:pPr>
             <a:r>
-              <a:t>EBITDA: 7,95 M€ (42,7%)</a:t>
+              <a:t>EBITDA: 7,85 M€ (43,5%)</a:t>
             </a:r>
           </a:p>
           <a:p>
@@ -14143,7 +14143,7 @@
               </a:defRPr>
             </a:pPr>
             <a:r>
-              <a:t>17,74 M€</a:t>
+              <a:t>17,18 M€</a:t>
             </a:r>
           </a:p>
           <a:p>
@@ -14158,7 +14158,7 @@
               </a:defRPr>
             </a:pPr>
             <a:r>
-              <a:t>EBITDA: 7,40 M€ (41,7%)</a:t>
+              <a:t>EBITDA: 7,30 M€ (42,5%)</a:t>
             </a:r>
           </a:p>
           <a:p>
@@ -14170,7 +14170,7 @@
               </a:defRPr>
             </a:pPr>
             <a:r>
-              <a:t>Hipótesis central aprobada, con crecimiento del +16,9% y control de costes.</a:t>
+              <a:t>Hipótesis central aprobada, con crecimiento del +13,2% y control de costes.</a:t>
             </a:r>
           </a:p>
         </p:txBody>
@@ -14262,7 +14262,7 @@
               </a:defRPr>
             </a:pPr>
             <a:r>
-              <a:t>16,85 M€</a:t>
+              <a:t>16,32 M€</a:t>
             </a:r>
           </a:p>
           <a:p>
@@ -14277,7 +14277,7 @@
               </a:defRPr>
             </a:pPr>
             <a:r>
-              <a:t>EBITDA: 6,85 M€ (40,7%)</a:t>
+              <a:t>EBITDA: 6,75 M€ (41,4%)</a:t>
             </a:r>
           </a:p>
           <a:p>

</xml_diff>